<commit_message>
add: More notes study material related to MDM
</commit_message>
<xml_diff>
--- a/ADS/PPTs/Recursive algorithm and Recurrence Relation.pptx
+++ b/ADS/PPTs/Recursive algorithm and Recurrence Relation.pptx
@@ -1,37 +1,37 @@
 
 <file path=ppt/presentation.xml><?xml version="1.0" encoding="utf-8"?>
-<p:presentation xmlns:a="http://schemas.openxmlformats.org/drawingml/2006/main" xmlns:r="http://schemas.openxmlformats.org/officeDocument/2006/relationships" xmlns:p="http://schemas.openxmlformats.org/presentationml/2006/main" saveSubsetFonts="1">
+<p:presentation xmlns:a="http://schemas.openxmlformats.org/drawingml/2006/main" xmlns:r="http://schemas.openxmlformats.org/officeDocument/2006/relationships" xmlns:p="http://schemas.openxmlformats.org/presentationml/2006/main">
   <p:sldMasterIdLst>
-    <p:sldMasterId id="2147483708" r:id="rId1"/>
+    <p:sldMasterId id="2147483648" r:id="rId1"/>
   </p:sldMasterIdLst>
   <p:sldIdLst>
-    <p:sldId id="256" r:id="rId2"/>
-    <p:sldId id="257" r:id="rId3"/>
-    <p:sldId id="258" r:id="rId4"/>
-    <p:sldId id="261" r:id="rId5"/>
-    <p:sldId id="262" r:id="rId6"/>
-    <p:sldId id="259" r:id="rId7"/>
-    <p:sldId id="260" r:id="rId8"/>
-    <p:sldId id="263" r:id="rId9"/>
-    <p:sldId id="264" r:id="rId10"/>
-    <p:sldId id="265" r:id="rId11"/>
-    <p:sldId id="266" r:id="rId12"/>
-    <p:sldId id="267" r:id="rId13"/>
-    <p:sldId id="268" r:id="rId14"/>
-    <p:sldId id="269" r:id="rId15"/>
-    <p:sldId id="270" r:id="rId16"/>
-    <p:sldId id="271" r:id="rId17"/>
-    <p:sldId id="272" r:id="rId18"/>
-    <p:sldId id="273" r:id="rId19"/>
-    <p:sldId id="274" r:id="rId20"/>
-    <p:sldId id="275" r:id="rId21"/>
-    <p:sldId id="276" r:id="rId22"/>
-    <p:sldId id="277" r:id="rId23"/>
-    <p:sldId id="278" r:id="rId24"/>
-    <p:sldId id="279" r:id="rId25"/>
-    <p:sldId id="280" r:id="rId26"/>
-    <p:sldId id="281" r:id="rId27"/>
-    <p:sldId id="282" r:id="rId28"/>
+    <p:sldId id="256" r:id="rId3"/>
+    <p:sldId id="257" r:id="rId4"/>
+    <p:sldId id="258" r:id="rId5"/>
+    <p:sldId id="261" r:id="rId6"/>
+    <p:sldId id="262" r:id="rId7"/>
+    <p:sldId id="259" r:id="rId8"/>
+    <p:sldId id="260" r:id="rId9"/>
+    <p:sldId id="263" r:id="rId10"/>
+    <p:sldId id="264" r:id="rId11"/>
+    <p:sldId id="265" r:id="rId12"/>
+    <p:sldId id="266" r:id="rId13"/>
+    <p:sldId id="267" r:id="rId14"/>
+    <p:sldId id="268" r:id="rId15"/>
+    <p:sldId id="269" r:id="rId16"/>
+    <p:sldId id="270" r:id="rId17"/>
+    <p:sldId id="271" r:id="rId18"/>
+    <p:sldId id="272" r:id="rId19"/>
+    <p:sldId id="273" r:id="rId20"/>
+    <p:sldId id="274" r:id="rId21"/>
+    <p:sldId id="275" r:id="rId22"/>
+    <p:sldId id="276" r:id="rId23"/>
+    <p:sldId id="277" r:id="rId24"/>
+    <p:sldId id="278" r:id="rId25"/>
+    <p:sldId id="279" r:id="rId26"/>
+    <p:sldId id="280" r:id="rId27"/>
+    <p:sldId id="281" r:id="rId28"/>
+    <p:sldId id="282" r:id="rId29"/>
   </p:sldIdLst>
   <p:sldSz cx="9144000" cy="6858000" type="screen4x3"/>
   <p:notesSz cx="6858000" cy="9144000"/>
@@ -306,8 +306,6 @@
           <a:p>
             <a:fld id="{1D8BD707-D9CF-40AE-B4C6-C98DA3205C09}" type="datetimeFigureOut">
               <a:rPr lang="en-US" smtClean="0"/>
-              <a:pPr/>
-              <a:t>7/28/2026</a:t>
             </a:fld>
             <a:endParaRPr lang="en-US"/>
           </a:p>
@@ -349,8 +347,6 @@
           <a:p>
             <a:fld id="{B6F15528-21DE-4FAA-801E-634DDDAF4B2B}" type="slidenum">
               <a:rPr lang="en-US" smtClean="0"/>
-              <a:pPr/>
-              <a:t>‹#›</a:t>
             </a:fld>
             <a:endParaRPr lang="en-US"/>
           </a:p>
@@ -424,6 +420,7 @@
               <a:rPr lang="en-US" smtClean="0"/>
               <a:t>Click to edit Master text styles</a:t>
             </a:r>
+            <a:endParaRPr lang="en-US" smtClean="0"/>
           </a:p>
           <a:p>
             <a:pPr lvl="1" eaLnBrk="1" latinLnBrk="0" hangingPunct="1"/>
@@ -431,6 +428,7 @@
               <a:rPr lang="en-US" smtClean="0"/>
               <a:t>Second level</a:t>
             </a:r>
+            <a:endParaRPr lang="en-US" smtClean="0"/>
           </a:p>
           <a:p>
             <a:pPr lvl="2" eaLnBrk="1" latinLnBrk="0" hangingPunct="1"/>
@@ -438,6 +436,7 @@
               <a:rPr lang="en-US" smtClean="0"/>
               <a:t>Third level</a:t>
             </a:r>
+            <a:endParaRPr lang="en-US" smtClean="0"/>
           </a:p>
           <a:p>
             <a:pPr lvl="3" eaLnBrk="1" latinLnBrk="0" hangingPunct="1"/>
@@ -445,6 +444,7 @@
               <a:rPr lang="en-US" smtClean="0"/>
               <a:t>Fourth level</a:t>
             </a:r>
+            <a:endParaRPr lang="en-US" smtClean="0"/>
           </a:p>
           <a:p>
             <a:pPr lvl="4" eaLnBrk="1" latinLnBrk="0" hangingPunct="1"/>
@@ -473,8 +473,6 @@
           <a:p>
             <a:fld id="{1D8BD707-D9CF-40AE-B4C6-C98DA3205C09}" type="datetimeFigureOut">
               <a:rPr lang="en-US" smtClean="0"/>
-              <a:pPr/>
-              <a:t>7/28/2026</a:t>
             </a:fld>
             <a:endParaRPr lang="en-US"/>
           </a:p>
@@ -516,8 +514,6 @@
           <a:p>
             <a:fld id="{B6F15528-21DE-4FAA-801E-634DDDAF4B2B}" type="slidenum">
               <a:rPr lang="en-US" smtClean="0"/>
-              <a:pPr/>
-              <a:t>‹#›</a:t>
             </a:fld>
             <a:endParaRPr lang="en-US"/>
           </a:p>
@@ -601,6 +597,7 @@
               <a:rPr lang="en-US" smtClean="0"/>
               <a:t>Click to edit Master text styles</a:t>
             </a:r>
+            <a:endParaRPr lang="en-US" smtClean="0"/>
           </a:p>
           <a:p>
             <a:pPr lvl="1" eaLnBrk="1" latinLnBrk="0" hangingPunct="1"/>
@@ -608,6 +605,7 @@
               <a:rPr lang="en-US" smtClean="0"/>
               <a:t>Second level</a:t>
             </a:r>
+            <a:endParaRPr lang="en-US" smtClean="0"/>
           </a:p>
           <a:p>
             <a:pPr lvl="2" eaLnBrk="1" latinLnBrk="0" hangingPunct="1"/>
@@ -615,6 +613,7 @@
               <a:rPr lang="en-US" smtClean="0"/>
               <a:t>Third level</a:t>
             </a:r>
+            <a:endParaRPr lang="en-US" smtClean="0"/>
           </a:p>
           <a:p>
             <a:pPr lvl="3" eaLnBrk="1" latinLnBrk="0" hangingPunct="1"/>
@@ -622,6 +621,7 @@
               <a:rPr lang="en-US" smtClean="0"/>
               <a:t>Fourth level</a:t>
             </a:r>
+            <a:endParaRPr lang="en-US" smtClean="0"/>
           </a:p>
           <a:p>
             <a:pPr lvl="4" eaLnBrk="1" latinLnBrk="0" hangingPunct="1"/>
@@ -650,8 +650,6 @@
           <a:p>
             <a:fld id="{1D8BD707-D9CF-40AE-B4C6-C98DA3205C09}" type="datetimeFigureOut">
               <a:rPr lang="en-US" smtClean="0"/>
-              <a:pPr/>
-              <a:t>7/28/2026</a:t>
             </a:fld>
             <a:endParaRPr lang="en-US"/>
           </a:p>
@@ -693,8 +691,6 @@
           <a:p>
             <a:fld id="{B6F15528-21DE-4FAA-801E-634DDDAF4B2B}" type="slidenum">
               <a:rPr lang="en-US" smtClean="0"/>
-              <a:pPr/>
-              <a:t>‹#›</a:t>
             </a:fld>
             <a:endParaRPr lang="en-US"/>
           </a:p>
@@ -768,6 +764,7 @@
               <a:rPr lang="en-US" smtClean="0"/>
               <a:t>Click to edit Master text styles</a:t>
             </a:r>
+            <a:endParaRPr lang="en-US" smtClean="0"/>
           </a:p>
           <a:p>
             <a:pPr lvl="1" eaLnBrk="1" latinLnBrk="0" hangingPunct="1"/>
@@ -775,6 +772,7 @@
               <a:rPr lang="en-US" smtClean="0"/>
               <a:t>Second level</a:t>
             </a:r>
+            <a:endParaRPr lang="en-US" smtClean="0"/>
           </a:p>
           <a:p>
             <a:pPr lvl="2" eaLnBrk="1" latinLnBrk="0" hangingPunct="1"/>
@@ -782,6 +780,7 @@
               <a:rPr lang="en-US" smtClean="0"/>
               <a:t>Third level</a:t>
             </a:r>
+            <a:endParaRPr lang="en-US" smtClean="0"/>
           </a:p>
           <a:p>
             <a:pPr lvl="3" eaLnBrk="1" latinLnBrk="0" hangingPunct="1"/>
@@ -789,6 +788,7 @@
               <a:rPr lang="en-US" smtClean="0"/>
               <a:t>Fourth level</a:t>
             </a:r>
+            <a:endParaRPr lang="en-US" smtClean="0"/>
           </a:p>
           <a:p>
             <a:pPr lvl="4" eaLnBrk="1" latinLnBrk="0" hangingPunct="1"/>
@@ -817,8 +817,6 @@
           <a:p>
             <a:fld id="{1D8BD707-D9CF-40AE-B4C6-C98DA3205C09}" type="datetimeFigureOut">
               <a:rPr lang="en-US" smtClean="0"/>
-              <a:pPr/>
-              <a:t>7/28/2026</a:t>
             </a:fld>
             <a:endParaRPr lang="en-US"/>
           </a:p>
@@ -860,8 +858,6 @@
           <a:p>
             <a:fld id="{B6F15528-21DE-4FAA-801E-634DDDAF4B2B}" type="slidenum">
               <a:rPr lang="en-US" smtClean="0"/>
-              <a:pPr/>
-              <a:t>‹#›</a:t>
             </a:fld>
             <a:endParaRPr lang="en-US"/>
           </a:p>
@@ -1041,6 +1037,7 @@
               <a:rPr kumimoji="0" lang="en-US" smtClean="0"/>
               <a:t>Click to edit Master text styles</a:t>
             </a:r>
+            <a:endParaRPr kumimoji="0" lang="en-US" smtClean="0"/>
           </a:p>
         </p:txBody>
       </p:sp>
@@ -1061,8 +1058,6 @@
           <a:p>
             <a:fld id="{1D8BD707-D9CF-40AE-B4C6-C98DA3205C09}" type="datetimeFigureOut">
               <a:rPr lang="en-US" smtClean="0"/>
-              <a:pPr/>
-              <a:t>7/28/2026</a:t>
             </a:fld>
             <a:endParaRPr lang="en-US"/>
           </a:p>
@@ -1104,8 +1099,6 @@
           <a:p>
             <a:fld id="{B6F15528-21DE-4FAA-801E-634DDDAF4B2B}" type="slidenum">
               <a:rPr lang="en-US" smtClean="0"/>
-              <a:pPr/>
-              <a:t>‹#›</a:t>
             </a:fld>
             <a:endParaRPr lang="en-US"/>
           </a:p>
@@ -1205,6 +1198,7 @@
               <a:rPr lang="en-US" smtClean="0"/>
               <a:t>Click to edit Master text styles</a:t>
             </a:r>
+            <a:endParaRPr lang="en-US" smtClean="0"/>
           </a:p>
           <a:p>
             <a:pPr lvl="1" eaLnBrk="1" latinLnBrk="0" hangingPunct="1"/>
@@ -1212,6 +1206,7 @@
               <a:rPr lang="en-US" smtClean="0"/>
               <a:t>Second level</a:t>
             </a:r>
+            <a:endParaRPr lang="en-US" smtClean="0"/>
           </a:p>
           <a:p>
             <a:pPr lvl="2" eaLnBrk="1" latinLnBrk="0" hangingPunct="1"/>
@@ -1219,6 +1214,7 @@
               <a:rPr lang="en-US" smtClean="0"/>
               <a:t>Third level</a:t>
             </a:r>
+            <a:endParaRPr lang="en-US" smtClean="0"/>
           </a:p>
           <a:p>
             <a:pPr lvl="3" eaLnBrk="1" latinLnBrk="0" hangingPunct="1"/>
@@ -1226,6 +1222,7 @@
               <a:rPr lang="en-US" smtClean="0"/>
               <a:t>Fourth level</a:t>
             </a:r>
+            <a:endParaRPr lang="en-US" smtClean="0"/>
           </a:p>
           <a:p>
             <a:pPr lvl="4" eaLnBrk="1" latinLnBrk="0" hangingPunct="1"/>
@@ -1278,6 +1275,7 @@
               <a:rPr lang="en-US" smtClean="0"/>
               <a:t>Click to edit Master text styles</a:t>
             </a:r>
+            <a:endParaRPr lang="en-US" smtClean="0"/>
           </a:p>
           <a:p>
             <a:pPr lvl="1" eaLnBrk="1" latinLnBrk="0" hangingPunct="1"/>
@@ -1285,6 +1283,7 @@
               <a:rPr lang="en-US" smtClean="0"/>
               <a:t>Second level</a:t>
             </a:r>
+            <a:endParaRPr lang="en-US" smtClean="0"/>
           </a:p>
           <a:p>
             <a:pPr lvl="2" eaLnBrk="1" latinLnBrk="0" hangingPunct="1"/>
@@ -1292,6 +1291,7 @@
               <a:rPr lang="en-US" smtClean="0"/>
               <a:t>Third level</a:t>
             </a:r>
+            <a:endParaRPr lang="en-US" smtClean="0"/>
           </a:p>
           <a:p>
             <a:pPr lvl="3" eaLnBrk="1" latinLnBrk="0" hangingPunct="1"/>
@@ -1299,6 +1299,7 @@
               <a:rPr lang="en-US" smtClean="0"/>
               <a:t>Fourth level</a:t>
             </a:r>
+            <a:endParaRPr lang="en-US" smtClean="0"/>
           </a:p>
           <a:p>
             <a:pPr lvl="4" eaLnBrk="1" latinLnBrk="0" hangingPunct="1"/>
@@ -1327,8 +1328,6 @@
           <a:p>
             <a:fld id="{1D8BD707-D9CF-40AE-B4C6-C98DA3205C09}" type="datetimeFigureOut">
               <a:rPr lang="en-US" smtClean="0"/>
-              <a:pPr/>
-              <a:t>7/28/2026</a:t>
             </a:fld>
             <a:endParaRPr lang="en-US"/>
           </a:p>
@@ -1370,8 +1369,6 @@
           <a:p>
             <a:fld id="{B6F15528-21DE-4FAA-801E-634DDDAF4B2B}" type="slidenum">
               <a:rPr lang="en-US" smtClean="0"/>
-              <a:pPr/>
-              <a:t>‹#›</a:t>
             </a:fld>
             <a:endParaRPr lang="en-US"/>
           </a:p>
@@ -1487,6 +1484,7 @@
               <a:rPr kumimoji="0" lang="en-US" smtClean="0"/>
               <a:t>Click to edit Master text styles</a:t>
             </a:r>
+            <a:endParaRPr kumimoji="0" lang="en-US" smtClean="0"/>
           </a:p>
         </p:txBody>
       </p:sp>
@@ -1541,6 +1539,7 @@
               <a:rPr kumimoji="0" lang="en-US" smtClean="0"/>
               <a:t>Click to edit Master text styles</a:t>
             </a:r>
+            <a:endParaRPr kumimoji="0" lang="en-US" smtClean="0"/>
           </a:p>
         </p:txBody>
       </p:sp>
@@ -1585,6 +1584,7 @@
               <a:rPr lang="en-US" smtClean="0"/>
               <a:t>Click to edit Master text styles</a:t>
             </a:r>
+            <a:endParaRPr lang="en-US" smtClean="0"/>
           </a:p>
           <a:p>
             <a:pPr lvl="1" eaLnBrk="1" latinLnBrk="0" hangingPunct="1"/>
@@ -1592,6 +1592,7 @@
               <a:rPr lang="en-US" smtClean="0"/>
               <a:t>Second level</a:t>
             </a:r>
+            <a:endParaRPr lang="en-US" smtClean="0"/>
           </a:p>
           <a:p>
             <a:pPr lvl="2" eaLnBrk="1" latinLnBrk="0" hangingPunct="1"/>
@@ -1599,6 +1600,7 @@
               <a:rPr lang="en-US" smtClean="0"/>
               <a:t>Third level</a:t>
             </a:r>
+            <a:endParaRPr lang="en-US" smtClean="0"/>
           </a:p>
           <a:p>
             <a:pPr lvl="3" eaLnBrk="1" latinLnBrk="0" hangingPunct="1"/>
@@ -1606,6 +1608,7 @@
               <a:rPr lang="en-US" smtClean="0"/>
               <a:t>Fourth level</a:t>
             </a:r>
+            <a:endParaRPr lang="en-US" smtClean="0"/>
           </a:p>
           <a:p>
             <a:pPr lvl="4" eaLnBrk="1" latinLnBrk="0" hangingPunct="1"/>
@@ -1658,6 +1661,7 @@
               <a:rPr lang="en-US" smtClean="0"/>
               <a:t>Click to edit Master text styles</a:t>
             </a:r>
+            <a:endParaRPr lang="en-US" smtClean="0"/>
           </a:p>
           <a:p>
             <a:pPr lvl="1" eaLnBrk="1" latinLnBrk="0" hangingPunct="1"/>
@@ -1665,6 +1669,7 @@
               <a:rPr lang="en-US" smtClean="0"/>
               <a:t>Second level</a:t>
             </a:r>
+            <a:endParaRPr lang="en-US" smtClean="0"/>
           </a:p>
           <a:p>
             <a:pPr lvl="2" eaLnBrk="1" latinLnBrk="0" hangingPunct="1"/>
@@ -1672,6 +1677,7 @@
               <a:rPr lang="en-US" smtClean="0"/>
               <a:t>Third level</a:t>
             </a:r>
+            <a:endParaRPr lang="en-US" smtClean="0"/>
           </a:p>
           <a:p>
             <a:pPr lvl="3" eaLnBrk="1" latinLnBrk="0" hangingPunct="1"/>
@@ -1679,6 +1685,7 @@
               <a:rPr lang="en-US" smtClean="0"/>
               <a:t>Fourth level</a:t>
             </a:r>
+            <a:endParaRPr lang="en-US" smtClean="0"/>
           </a:p>
           <a:p>
             <a:pPr lvl="4" eaLnBrk="1" latinLnBrk="0" hangingPunct="1"/>
@@ -1707,8 +1714,6 @@
           <a:p>
             <a:fld id="{1D8BD707-D9CF-40AE-B4C6-C98DA3205C09}" type="datetimeFigureOut">
               <a:rPr lang="en-US" smtClean="0"/>
-              <a:pPr/>
-              <a:t>7/28/2026</a:t>
             </a:fld>
             <a:endParaRPr lang="en-US"/>
           </a:p>
@@ -1750,8 +1755,6 @@
           <a:p>
             <a:fld id="{B6F15528-21DE-4FAA-801E-634DDDAF4B2B}" type="slidenum">
               <a:rPr lang="en-US" smtClean="0"/>
-              <a:pPr/>
-              <a:t>‹#›</a:t>
             </a:fld>
             <a:endParaRPr lang="en-US"/>
           </a:p>
@@ -1859,8 +1862,6 @@
           <a:p>
             <a:fld id="{1D8BD707-D9CF-40AE-B4C6-C98DA3205C09}" type="datetimeFigureOut">
               <a:rPr lang="en-US" smtClean="0"/>
-              <a:pPr/>
-              <a:t>7/28/2026</a:t>
             </a:fld>
             <a:endParaRPr lang="en-US"/>
           </a:p>
@@ -1902,8 +1903,6 @@
           <a:p>
             <a:fld id="{B6F15528-21DE-4FAA-801E-634DDDAF4B2B}" type="slidenum">
               <a:rPr lang="en-US" smtClean="0"/>
-              <a:pPr/>
-              <a:t>‹#›</a:t>
             </a:fld>
             <a:endParaRPr lang="en-US"/>
           </a:p>
@@ -1951,8 +1950,6 @@
           <a:p>
             <a:fld id="{1D8BD707-D9CF-40AE-B4C6-C98DA3205C09}" type="datetimeFigureOut">
               <a:rPr lang="en-US" smtClean="0"/>
-              <a:pPr/>
-              <a:t>7/28/2026</a:t>
             </a:fld>
             <a:endParaRPr lang="en-US"/>
           </a:p>
@@ -1994,8 +1991,6 @@
           <a:p>
             <a:fld id="{B6F15528-21DE-4FAA-801E-634DDDAF4B2B}" type="slidenum">
               <a:rPr lang="en-US" smtClean="0"/>
-              <a:pPr/>
-              <a:t>‹#›</a:t>
             </a:fld>
             <a:endParaRPr lang="en-US"/>
           </a:p>
@@ -2121,6 +2116,7 @@
               <a:rPr kumimoji="0" lang="en-US" smtClean="0"/>
               <a:t>Click to edit Master text styles</a:t>
             </a:r>
+            <a:endParaRPr kumimoji="0" lang="en-US" smtClean="0"/>
           </a:p>
         </p:txBody>
       </p:sp>
@@ -2165,6 +2161,7 @@
               <a:rPr lang="en-US" smtClean="0"/>
               <a:t>Click to edit Master text styles</a:t>
             </a:r>
+            <a:endParaRPr lang="en-US" smtClean="0"/>
           </a:p>
           <a:p>
             <a:pPr lvl="1" eaLnBrk="1" latinLnBrk="0" hangingPunct="1"/>
@@ -2172,6 +2169,7 @@
               <a:rPr lang="en-US" smtClean="0"/>
               <a:t>Second level</a:t>
             </a:r>
+            <a:endParaRPr lang="en-US" smtClean="0"/>
           </a:p>
           <a:p>
             <a:pPr lvl="2" eaLnBrk="1" latinLnBrk="0" hangingPunct="1"/>
@@ -2179,6 +2177,7 @@
               <a:rPr lang="en-US" smtClean="0"/>
               <a:t>Third level</a:t>
             </a:r>
+            <a:endParaRPr lang="en-US" smtClean="0"/>
           </a:p>
           <a:p>
             <a:pPr lvl="3" eaLnBrk="1" latinLnBrk="0" hangingPunct="1"/>
@@ -2186,6 +2185,7 @@
               <a:rPr lang="en-US" smtClean="0"/>
               <a:t>Fourth level</a:t>
             </a:r>
+            <a:endParaRPr lang="en-US" smtClean="0"/>
           </a:p>
           <a:p>
             <a:pPr lvl="4" eaLnBrk="1" latinLnBrk="0" hangingPunct="1"/>
@@ -2214,8 +2214,6 @@
           <a:p>
             <a:fld id="{1D8BD707-D9CF-40AE-B4C6-C98DA3205C09}" type="datetimeFigureOut">
               <a:rPr lang="en-US" smtClean="0"/>
-              <a:pPr/>
-              <a:t>7/28/2026</a:t>
             </a:fld>
             <a:endParaRPr lang="en-US"/>
           </a:p>
@@ -2257,8 +2255,6 @@
           <a:p>
             <a:fld id="{B6F15528-21DE-4FAA-801E-634DDDAF4B2B}" type="slidenum">
               <a:rPr lang="en-US" smtClean="0"/>
-              <a:pPr/>
-              <a:t>‹#›</a:t>
             </a:fld>
             <a:endParaRPr lang="en-US"/>
           </a:p>
@@ -2273,7 +2269,7 @@
 </file>
 
 <file path=ppt/slideLayouts/slideLayout9.xml><?xml version="1.0" encoding="utf-8"?>
-<p:sldLayout xmlns:a="http://schemas.openxmlformats.org/drawingml/2006/main" xmlns:r="http://schemas.openxmlformats.org/officeDocument/2006/relationships" xmlns:p="http://schemas.openxmlformats.org/presentationml/2006/main" showMasterSp="0" type="picTx" preserve="1">
+<p:sldLayout xmlns:a="http://schemas.openxmlformats.org/drawingml/2006/main" xmlns:r="http://schemas.openxmlformats.org/officeDocument/2006/relationships" xmlns:p="http://schemas.openxmlformats.org/presentationml/2006/main" type="picTx" preserve="1" showMasterSp="0">
   <p:cSld name="Picture with Caption">
     <p:spTree>
       <p:nvGrpSpPr>
@@ -2484,6 +2480,7 @@
               <a:rPr kumimoji="0" lang="en-US" smtClean="0"/>
               <a:t>Click to edit Master text styles</a:t>
             </a:r>
+            <a:endParaRPr kumimoji="0" lang="en-US" smtClean="0"/>
           </a:p>
         </p:txBody>
       </p:sp>
@@ -2504,8 +2501,6 @@
           <a:p>
             <a:fld id="{1D8BD707-D9CF-40AE-B4C6-C98DA3205C09}" type="datetimeFigureOut">
               <a:rPr lang="en-US" smtClean="0"/>
-              <a:pPr/>
-              <a:t>7/28/2026</a:t>
             </a:fld>
             <a:endParaRPr lang="en-US"/>
           </a:p>
@@ -2552,8 +2547,6 @@
           <a:p>
             <a:fld id="{B6F15528-21DE-4FAA-801E-634DDDAF4B2B}" type="slidenum">
               <a:rPr lang="en-US" smtClean="0"/>
-              <a:pPr/>
-              <a:t>‹#›</a:t>
             </a:fld>
             <a:endParaRPr lang="en-US"/>
           </a:p>
@@ -2608,9 +2601,7 @@
       <p:sp>
         <p:nvSpPr>
           <p:cNvPr id="10" name="Freeform 9"/>
-          <p:cNvSpPr>
-            <a:spLocks/>
-          </p:cNvSpPr>
+          <p:cNvSpPr/>
           <p:nvPr/>
         </p:nvSpPr>
         <p:spPr bwMode="auto">
@@ -2751,9 +2742,7 @@
       <p:sp>
         <p:nvSpPr>
           <p:cNvPr id="11" name="Freeform 10"/>
-          <p:cNvSpPr>
-            <a:spLocks/>
-          </p:cNvSpPr>
+          <p:cNvSpPr/>
           <p:nvPr/>
         </p:nvSpPr>
         <p:spPr bwMode="auto">
@@ -2894,9 +2883,7 @@
       <p:sp>
         <p:nvSpPr>
           <p:cNvPr id="7" name="Freeform 6"/>
-          <p:cNvSpPr>
-            <a:spLocks/>
-          </p:cNvSpPr>
+          <p:cNvSpPr/>
           <p:nvPr/>
         </p:nvSpPr>
         <p:spPr bwMode="auto">
@@ -3037,9 +3024,7 @@
       <p:sp>
         <p:nvSpPr>
           <p:cNvPr id="8" name="Freeform 7"/>
-          <p:cNvSpPr>
-            <a:spLocks/>
-          </p:cNvSpPr>
+          <p:cNvSpPr/>
           <p:nvPr/>
         </p:nvSpPr>
         <p:spPr bwMode="auto">
@@ -3210,6 +3195,7 @@
               <a:rPr kumimoji="0" lang="en-US" smtClean="0"/>
               <a:t>Click to edit Master text styles</a:t>
             </a:r>
+            <a:endParaRPr kumimoji="0" lang="en-US" smtClean="0"/>
           </a:p>
           <a:p>
             <a:pPr lvl="1" eaLnBrk="1" latinLnBrk="0" hangingPunct="1"/>
@@ -3217,6 +3203,7 @@
               <a:rPr kumimoji="0" lang="en-US" smtClean="0"/>
               <a:t>Second level</a:t>
             </a:r>
+            <a:endParaRPr kumimoji="0" lang="en-US" smtClean="0"/>
           </a:p>
           <a:p>
             <a:pPr lvl="2" eaLnBrk="1" latinLnBrk="0" hangingPunct="1"/>
@@ -3224,6 +3211,7 @@
               <a:rPr kumimoji="0" lang="en-US" smtClean="0"/>
               <a:t>Third level</a:t>
             </a:r>
+            <a:endParaRPr kumimoji="0" lang="en-US" smtClean="0"/>
           </a:p>
           <a:p>
             <a:pPr lvl="3" eaLnBrk="1" latinLnBrk="0" hangingPunct="1"/>
@@ -3231,6 +3219,7 @@
               <a:rPr kumimoji="0" lang="en-US" smtClean="0"/>
               <a:t>Fourth level</a:t>
             </a:r>
+            <a:endParaRPr kumimoji="0" lang="en-US" smtClean="0"/>
           </a:p>
           <a:p>
             <a:pPr lvl="4" eaLnBrk="1" latinLnBrk="0" hangingPunct="1"/>
@@ -3277,8 +3266,6 @@
           <a:p>
             <a:fld id="{1D8BD707-D9CF-40AE-B4C6-C98DA3205C09}" type="datetimeFigureOut">
               <a:rPr lang="en-US" smtClean="0"/>
-              <a:pPr/>
-              <a:t>7/28/2026</a:t>
             </a:fld>
             <a:endParaRPr lang="en-US"/>
           </a:p>
@@ -3356,8 +3343,6 @@
           <a:p>
             <a:fld id="{B6F15528-21DE-4FAA-801E-634DDDAF4B2B}" type="slidenum">
               <a:rPr lang="en-US" smtClean="0"/>
-              <a:pPr/>
-              <a:t>‹#›</a:t>
             </a:fld>
             <a:endParaRPr lang="en-US"/>
           </a:p>
@@ -3380,9 +3365,7 @@
         <p:sp>
           <p:nvSpPr>
             <p:cNvPr id="12" name="Freeform 11"/>
-            <p:cNvSpPr>
-              <a:spLocks/>
-            </p:cNvSpPr>
+            <p:cNvSpPr/>
             <p:nvPr/>
           </p:nvSpPr>
           <p:spPr bwMode="auto">
@@ -3482,9 +3465,7 @@
         <p:sp>
           <p:nvSpPr>
             <p:cNvPr id="13" name="Freeform 12"/>
-            <p:cNvSpPr>
-              <a:spLocks/>
-            </p:cNvSpPr>
+            <p:cNvSpPr/>
             <p:nvPr/>
           </p:nvSpPr>
           <p:spPr bwMode="auto">
@@ -3581,17 +3562,17 @@
   </p:cSld>
   <p:clrMap bg1="lt1" tx1="dk1" bg2="lt2" tx2="dk2" accent1="accent1" accent2="accent2" accent3="accent3" accent4="accent4" accent5="accent5" accent6="accent6" hlink="hlink" folHlink="folHlink"/>
   <p:sldLayoutIdLst>
-    <p:sldLayoutId id="2147483709" r:id="rId1"/>
-    <p:sldLayoutId id="2147483710" r:id="rId2"/>
-    <p:sldLayoutId id="2147483711" r:id="rId3"/>
-    <p:sldLayoutId id="2147483712" r:id="rId4"/>
-    <p:sldLayoutId id="2147483713" r:id="rId5"/>
-    <p:sldLayoutId id="2147483714" r:id="rId6"/>
-    <p:sldLayoutId id="2147483715" r:id="rId7"/>
-    <p:sldLayoutId id="2147483716" r:id="rId8"/>
-    <p:sldLayoutId id="2147483717" r:id="rId9"/>
-    <p:sldLayoutId id="2147483718" r:id="rId10"/>
-    <p:sldLayoutId id="2147483719" r:id="rId11"/>
+    <p:sldLayoutId id="2147483649" r:id="rId1"/>
+    <p:sldLayoutId id="2147483650" r:id="rId2"/>
+    <p:sldLayoutId id="2147483651" r:id="rId3"/>
+    <p:sldLayoutId id="2147483652" r:id="rId4"/>
+    <p:sldLayoutId id="2147483653" r:id="rId5"/>
+    <p:sldLayoutId id="2147483654" r:id="rId6"/>
+    <p:sldLayoutId id="2147483655" r:id="rId7"/>
+    <p:sldLayoutId id="2147483656" r:id="rId8"/>
+    <p:sldLayoutId id="2147483657" r:id="rId9"/>
+    <p:sldLayoutId id="2147483658" r:id="rId10"/>
+    <p:sldLayoutId id="2147483659" r:id="rId11"/>
   </p:sldLayoutIdLst>
   <p:txStyles>
     <p:titleStyle>
@@ -3634,7 +3615,7 @@
           <a:cs typeface="+mn-cs"/>
         </a:defRPr>
       </a:lvl1pPr>
-      <a:lvl2pPr marL="640080" indent="-246888" algn="l" rtl="0" eaLnBrk="1" latinLnBrk="0" hangingPunct="1">
+      <a:lvl2pPr marL="640080" indent="-247015" algn="l" rtl="0" eaLnBrk="1" latinLnBrk="0" hangingPunct="1">
         <a:spcBef>
           <a:spcPct val="20000"/>
         </a:spcBef>
@@ -3653,7 +3634,7 @@
           <a:cs typeface="+mn-cs"/>
         </a:defRPr>
       </a:lvl2pPr>
-      <a:lvl3pPr marL="914400" indent="-246888" algn="l" rtl="0" eaLnBrk="1" latinLnBrk="0" hangingPunct="1">
+      <a:lvl3pPr marL="914400" indent="-247015" algn="l" rtl="0" eaLnBrk="1" latinLnBrk="0" hangingPunct="1">
         <a:spcBef>
           <a:spcPct val="20000"/>
         </a:spcBef>
@@ -3672,7 +3653,7 @@
           <a:cs typeface="+mn-cs"/>
         </a:defRPr>
       </a:lvl3pPr>
-      <a:lvl4pPr marL="1188720" indent="-210312" algn="l" rtl="0" eaLnBrk="1" latinLnBrk="0" hangingPunct="1">
+      <a:lvl4pPr marL="1188720" indent="-210185" algn="l" rtl="0" eaLnBrk="1" latinLnBrk="0" hangingPunct="1">
         <a:spcBef>
           <a:spcPct val="20000"/>
         </a:spcBef>
@@ -3691,7 +3672,7 @@
           <a:cs typeface="+mn-cs"/>
         </a:defRPr>
       </a:lvl4pPr>
-      <a:lvl5pPr marL="1463040" indent="-210312" algn="l" rtl="0" eaLnBrk="1" latinLnBrk="0" hangingPunct="1">
+      <a:lvl5pPr marL="1463040" indent="-210185" algn="l" rtl="0" eaLnBrk="1" latinLnBrk="0" hangingPunct="1">
         <a:spcBef>
           <a:spcPct val="20000"/>
         </a:spcBef>
@@ -3710,7 +3691,7 @@
           <a:cs typeface="+mn-cs"/>
         </a:defRPr>
       </a:lvl5pPr>
-      <a:lvl6pPr marL="1737360" indent="-210312" algn="l" rtl="0" eaLnBrk="1" latinLnBrk="0" hangingPunct="1">
+      <a:lvl6pPr marL="1737360" indent="-210185" algn="l" rtl="0" eaLnBrk="1" latinLnBrk="0" hangingPunct="1">
         <a:spcBef>
           <a:spcPct val="20000"/>
         </a:spcBef>
@@ -4003,6 +3984,7 @@
               <a:rPr lang="en-US" dirty="0" smtClean="0"/>
               <a:t>The recursion tree method is used to analyze the time complexity of recursive algorithms by visually representing the recurrence as a tree. Each node of the tree represents the work done in a single recursive call, and each level represents one stage of the recursion. Below are the steps used to find time complexity using recursion tree method.</a:t>
             </a:r>
+            <a:endParaRPr lang="en-US" dirty="0" smtClean="0"/>
           </a:p>
           <a:p>
             <a:pPr fontAlgn="base"/>
@@ -4012,7 +3994,7 @@
             </a:r>
             <a:r>
               <a:rPr lang="en-US" u="sng" dirty="0" smtClean="0">
-                <a:hlinkClick r:id="rId2"/>
+                <a:hlinkClick r:id="rId1"/>
               </a:rPr>
               <a:t>tree</a:t>
             </a:r>
@@ -4020,6 +4002,7 @@
               <a:rPr lang="en-US" dirty="0" smtClean="0"/>
               <a:t> for given recurrence relation</a:t>
             </a:r>
+            <a:endParaRPr lang="en-US" dirty="0" smtClean="0"/>
           </a:p>
           <a:p>
             <a:pPr fontAlgn="base"/>
@@ -4027,6 +4010,7 @@
               <a:rPr lang="en-US" dirty="0" smtClean="0"/>
               <a:t>Calculate the cost at each level and count the total no of levels in the recursion tree.</a:t>
             </a:r>
+            <a:endParaRPr lang="en-US" dirty="0" smtClean="0"/>
           </a:p>
           <a:p>
             <a:pPr fontAlgn="base"/>
@@ -4034,6 +4018,7 @@
               <a:rPr lang="en-US" dirty="0" smtClean="0"/>
               <a:t>Sum up the cost of all the levels in the recursive tree</a:t>
             </a:r>
+            <a:endParaRPr lang="en-US" dirty="0" smtClean="0"/>
           </a:p>
           <a:p>
             <a:endParaRPr lang="en-US" dirty="0"/>
@@ -4102,6 +4087,7 @@
               <a:rPr lang="en-US" dirty="0" smtClean="0"/>
               <a:t> n) {</a:t>
             </a:r>
+            <a:endParaRPr lang="en-US" dirty="0" smtClean="0"/>
           </a:p>
           <a:p>
             <a:pPr>
@@ -4109,12 +4095,9 @@
             </a:pPr>
             <a:r>
               <a:rPr lang="en-US" dirty="0" smtClean="0"/>
-              <a:t>    </a:t>
-            </a:r>
-            <a:r>
-              <a:rPr lang="en-US" dirty="0" smtClean="0"/>
-              <a:t>if (n &lt;= 1)</a:t>
-            </a:r>
+              <a:t>    if (n &lt;= 1)</a:t>
+            </a:r>
+            <a:endParaRPr lang="en-US" dirty="0" smtClean="0"/>
           </a:p>
           <a:p>
             <a:pPr>
@@ -4124,6 +4107,7 @@
               <a:rPr lang="en-US" dirty="0" smtClean="0"/>
               <a:t>        return;</a:t>
             </a:r>
+            <a:endParaRPr lang="en-US" dirty="0" smtClean="0"/>
           </a:p>
           <a:p>
             <a:pPr>
@@ -4131,12 +4115,9 @@
             </a:pPr>
             <a:r>
               <a:rPr lang="en-US" dirty="0" smtClean="0"/>
-              <a:t>    </a:t>
-            </a:r>
-            <a:r>
-              <a:rPr lang="en-US" dirty="0" smtClean="0"/>
-              <a:t>fun(n / 2);</a:t>
-            </a:r>
+              <a:t>    fun(n / 2);</a:t>
+            </a:r>
+            <a:endParaRPr lang="en-US" dirty="0" smtClean="0"/>
           </a:p>
           <a:p>
             <a:pPr>
@@ -4146,6 +4127,7 @@
               <a:rPr lang="en-US" dirty="0" smtClean="0"/>
               <a:t>    fun(n / 2);</a:t>
             </a:r>
+            <a:endParaRPr lang="en-US" dirty="0" smtClean="0"/>
           </a:p>
           <a:p>
             <a:pPr>
@@ -4153,11 +4135,7 @@
             </a:pPr>
             <a:r>
               <a:rPr lang="en-US" dirty="0" smtClean="0"/>
-              <a:t>    </a:t>
-            </a:r>
-            <a:r>
-              <a:rPr lang="en-US" dirty="0" smtClean="0"/>
-              <a:t>for (</a:t>
+              <a:t>    for (</a:t>
             </a:r>
             <a:r>
               <a:rPr lang="en-US" dirty="0" err="1" smtClean="0"/>
@@ -4191,6 +4169,7 @@
               <a:rPr lang="en-US" dirty="0" smtClean="0"/>
               <a:t>++) {</a:t>
             </a:r>
+            <a:endParaRPr lang="en-US" dirty="0" smtClean="0"/>
           </a:p>
           <a:p>
             <a:pPr>
@@ -4208,6 +4187,7 @@
               <a:rPr lang="en-US" dirty="0" smtClean="0"/>
               <a:t> &lt;&lt; "GFG ";</a:t>
             </a:r>
+            <a:endParaRPr lang="en-US" dirty="0" smtClean="0"/>
           </a:p>
           <a:p>
             <a:pPr>
@@ -4217,6 +4197,7 @@
               <a:rPr lang="en-US" dirty="0" smtClean="0"/>
               <a:t>    }</a:t>
             </a:r>
+            <a:endParaRPr lang="en-US" dirty="0" smtClean="0"/>
           </a:p>
           <a:p>
             <a:pPr>
@@ -4226,37 +4207,27 @@
               <a:rPr lang="en-US" dirty="0" smtClean="0"/>
               <a:t>}</a:t>
             </a:r>
+            <a:endParaRPr lang="en-US" dirty="0" smtClean="0"/>
           </a:p>
           <a:p>
             <a:pPr fontAlgn="base"/>
             <a:r>
               <a:rPr lang="en-US" b="1" dirty="0" smtClean="0"/>
-              <a:t>Understanding the Recursion for This </a:t>
-            </a:r>
+              <a:t>Understanding the Recursion for This Code</a:t>
+            </a:r>
+            <a:endParaRPr lang="en-US" b="1" dirty="0" smtClean="0"/>
+          </a:p>
+          <a:p>
+            <a:pPr fontAlgn="base">
+              <a:buNone/>
+            </a:pPr>
             <a:r>
               <a:rPr lang="en-US" b="1" dirty="0" smtClean="0"/>
-              <a:t>Code</a:t>
-            </a:r>
-          </a:p>
-          <a:p>
-            <a:pPr fontAlgn="base">
-              <a:buNone/>
-            </a:pPr>
-            <a:r>
-              <a:rPr lang="en-US" b="1" dirty="0" smtClean="0"/>
-              <a:t> </a:t>
-            </a:r>
-            <a:r>
-              <a:rPr lang="en-US" b="1" dirty="0" smtClean="0"/>
-              <a:t>   </a:t>
-            </a:r>
-            <a:r>
-              <a:rPr lang="en-US" dirty="0" smtClean="0"/>
-              <a:t>The </a:t>
-            </a:r>
-            <a:r>
-              <a:rPr lang="en-US" dirty="0" smtClean="0"/>
-              <a:t>function makes two recursive calls, each on a </a:t>
+              <a:t>    </a:t>
+            </a:r>
+            <a:r>
+              <a:rPr lang="en-US" dirty="0" smtClean="0"/>
+              <a:t>The function makes two recursive calls, each on a </a:t>
             </a:r>
             <a:r>
               <a:rPr lang="en-US" dirty="0" err="1" smtClean="0"/>
@@ -4266,6 +4237,7 @@
               <a:rPr lang="en-US" dirty="0" smtClean="0"/>
               <a:t> of size n/2. After both recursive calls return, it performs a loop that prints "GFG" exactly n times, which is linear work for each function call. The recursion stops when n ≤ 1.</a:t>
             </a:r>
+            <a:endParaRPr lang="en-US" dirty="0" smtClean="0"/>
           </a:p>
           <a:p>
             <a:pPr fontAlgn="base"/>
@@ -4273,6 +4245,7 @@
               <a:rPr lang="en-US" b="1" dirty="0" smtClean="0"/>
               <a:t>Writing the Recurrence Relation</a:t>
             </a:r>
+            <a:endParaRPr lang="en-US" b="1" dirty="0" smtClean="0"/>
           </a:p>
           <a:p>
             <a:pPr fontAlgn="base">
@@ -4280,11 +4253,7 @@
             </a:pPr>
             <a:r>
               <a:rPr lang="en-US" dirty="0" smtClean="0"/>
-              <a:t>    Each </a:t>
-            </a:r>
-            <a:r>
-              <a:rPr lang="en-US" dirty="0" smtClean="0"/>
-              <a:t>function call makes two recursive calls of size n/2 and performs linear work after the recursion.</a:t>
+              <a:t>    Each function call makes two recursive calls of size n/2 and performs linear work after the recursion.</a:t>
             </a:r>
             <a:br>
               <a:rPr lang="en-US" dirty="0" smtClean="0"/>
@@ -4293,6 +4262,7 @@
               <a:rPr lang="en-US" dirty="0" smtClean="0"/>
               <a:t>Therefore, the recurrence relation is: T(n) = 2T(n/2) + O(n)</a:t>
             </a:r>
+            <a:endParaRPr lang="en-US" dirty="0" smtClean="0"/>
           </a:p>
           <a:p>
             <a:pPr>
@@ -4336,7 +4306,7 @@
           <p:nvPr/>
         </p:nvPicPr>
         <p:blipFill>
-          <a:blip r:embed="rId2" cstate="print"/>
+          <a:blip r:embed="rId1" cstate="print"/>
           <a:srcRect/>
           <a:stretch>
             <a:fillRect/>
@@ -4368,7 +4338,7 @@
           <p:nvPr/>
         </p:nvPicPr>
         <p:blipFill>
-          <a:blip r:embed="rId3" cstate="print"/>
+          <a:blip r:embed="rId2" cstate="print"/>
           <a:srcRect/>
           <a:stretch>
             <a:fillRect/>
@@ -4435,11 +4405,7 @@
           <a:noFill/>
         </p:spPr>
         <p:txBody>
-          <a:bodyPr vert="horz" wrap="square" lIns="91440" tIns="45720" rIns="91440" bIns="45720" numCol="1" anchor="t" anchorCtr="0" compatLnSpc="1">
-            <a:prstTxWarp prst="textNoShape">
-              <a:avLst/>
-            </a:prstTxWarp>
-          </a:bodyPr>
+          <a:bodyPr vert="horz" wrap="square" lIns="91440" tIns="45720" rIns="91440" bIns="45720" numCol="1" anchor="t" anchorCtr="0" compatLnSpc="1"/>
           <a:lstStyle/>
           <a:p>
             <a:endParaRPr lang="en-US"/>
@@ -4455,7 +4421,7 @@
           <p:nvPr/>
         </p:nvPicPr>
         <p:blipFill>
-          <a:blip r:embed="rId2" cstate="print"/>
+          <a:blip r:embed="rId1" cstate="print"/>
           <a:srcRect/>
           <a:stretch>
             <a:fillRect/>
@@ -4528,12 +4494,9 @@
             <a:pPr fontAlgn="base"/>
             <a:r>
               <a:rPr lang="en-US" dirty="0" smtClean="0"/>
-              <a:t>To </a:t>
-            </a:r>
-            <a:r>
-              <a:rPr lang="en-US" dirty="0" smtClean="0"/>
-              <a:t>find T(n), we analyze the recursion tree and sum the cost at each level.</a:t>
-            </a:r>
+              <a:t>To find T(n), we analyze the recursion tree and sum the cost at each level.</a:t>
+            </a:r>
+            <a:endParaRPr lang="en-US" dirty="0" smtClean="0"/>
           </a:p>
           <a:p>
             <a:pPr fontAlgn="base"/>
@@ -4553,6 +4516,7 @@
               <a:rPr lang="en-US" dirty="0" smtClean="0"/>
               <a:t>.</a:t>
             </a:r>
+            <a:endParaRPr lang="en-US" dirty="0" smtClean="0"/>
           </a:p>
           <a:p>
             <a:pPr fontAlgn="base"/>
@@ -4587,6 +4551,7 @@
               <a:rPr lang="en-US" dirty="0" smtClean="0"/>
               <a:t> </a:t>
             </a:r>
+            <a:endParaRPr lang="en-US" dirty="0" smtClean="0"/>
           </a:p>
           <a:p>
             <a:pPr fontAlgn="base"/>
@@ -4629,6 +4594,7 @@
               <a:rPr lang="en-US" dirty="0" smtClean="0"/>
               <a:t>.</a:t>
             </a:r>
+            <a:endParaRPr lang="en-US" dirty="0" smtClean="0"/>
           </a:p>
           <a:p>
             <a:pPr fontAlgn="base">
@@ -4638,6 +4604,7 @@
               <a:rPr lang="en-US" b="1" dirty="0" smtClean="0"/>
               <a:t>Total Work Across All Levels</a:t>
             </a:r>
+            <a:endParaRPr lang="en-US" b="1" dirty="0" smtClean="0"/>
           </a:p>
           <a:p>
             <a:pPr fontAlgn="base"/>
@@ -4650,16 +4617,9 @@
             </a:br>
             <a:r>
               <a:rPr lang="en-US" dirty="0" smtClean="0"/>
-              <a:t>Hence, the height of the recursion tree is </a:t>
-            </a:r>
-            <a:r>
-              <a:rPr lang="en-US" dirty="0" smtClean="0"/>
-              <a:t>log ⁡</a:t>
-            </a:r>
-            <a:r>
-              <a:rPr lang="en-US" dirty="0" smtClean="0"/>
-              <a:t>n.</a:t>
-            </a:r>
+              <a:t>Hence, the height of the recursion tree is log ⁡n.</a:t>
+            </a:r>
+            <a:endParaRPr lang="en-US" dirty="0" smtClean="0"/>
           </a:p>
           <a:p>
             <a:pPr fontAlgn="base"/>
@@ -4721,6 +4681,7 @@
               <a:rPr lang="en-US" dirty="0" smtClean="0"/>
               <a:t> log n</a:t>
             </a:r>
+            <a:endParaRPr lang="en-US" dirty="0" smtClean="0"/>
           </a:p>
           <a:p>
             <a:pPr fontAlgn="base"/>
@@ -4732,6 +4693,7 @@
               <a:rPr lang="en-US" dirty="0" smtClean="0"/>
               <a:t> T(n) = O(n log n)</a:t>
             </a:r>
+            <a:endParaRPr lang="en-US" dirty="0" smtClean="0"/>
           </a:p>
           <a:p>
             <a:endParaRPr lang="en-US" dirty="0"/>
@@ -4813,15 +4775,7 @@
           <a:p>
             <a:r>
               <a:rPr lang="en-US" dirty="0" smtClean="0"/>
-              <a:t>The Master Theorem is a tool used to solve recurrence relations that arise in the analysis of divide-and-conquer algorithms</a:t>
-            </a:r>
-            <a:r>
-              <a:rPr lang="en-US" dirty="0" smtClean="0"/>
-              <a:t>.</a:t>
-            </a:r>
-            <a:r>
-              <a:rPr lang="en-US" dirty="0" smtClean="0"/>
-              <a:t> </a:t>
+              <a:t>The Master Theorem is a tool used to solve recurrence relations that arise in the analysis of divide-and-conquer algorithms. </a:t>
             </a:r>
             <a:endParaRPr lang="en-US" dirty="0"/>
           </a:p>
@@ -4846,11 +4800,7 @@
           <a:noFill/>
         </p:spPr>
         <p:txBody>
-          <a:bodyPr vert="horz" wrap="square" lIns="91440" tIns="45720" rIns="91440" bIns="45720" numCol="1" anchor="t" anchorCtr="0" compatLnSpc="1">
-            <a:prstTxWarp prst="textNoShape">
-              <a:avLst/>
-            </a:prstTxWarp>
-          </a:bodyPr>
+          <a:bodyPr vert="horz" wrap="square" lIns="91440" tIns="45720" rIns="91440" bIns="45720" numCol="1" anchor="t" anchorCtr="0" compatLnSpc="1"/>
           <a:lstStyle/>
           <a:p>
             <a:endParaRPr lang="en-US"/>
@@ -4866,7 +4816,7 @@
           <p:nvPr/>
         </p:nvPicPr>
         <p:blipFill>
-          <a:blip r:embed="rId2" cstate="print"/>
+          <a:blip r:embed="rId1" cstate="print"/>
           <a:srcRect/>
           <a:stretch>
             <a:fillRect/>
@@ -4892,9 +4842,7 @@
       <p:sp>
         <p:nvSpPr>
           <p:cNvPr id="9" name="Content Placeholder 2"/>
-          <p:cNvSpPr txBox="1">
-            <a:spLocks/>
-          </p:cNvSpPr>
+          <p:cNvSpPr txBox="1"/>
           <p:nvPr/>
         </p:nvSpPr>
         <p:spPr>
@@ -4917,6 +4865,7 @@
               <a:rPr lang="en-US" sz="2800" dirty="0" smtClean="0"/>
               <a:t>where:</a:t>
             </a:r>
+            <a:endParaRPr lang="en-US" sz="2800" dirty="0" smtClean="0"/>
           </a:p>
           <a:p>
             <a:pPr fontAlgn="base"/>
@@ -4924,6 +4873,7 @@
               <a:rPr lang="en-US" sz="2800" dirty="0" smtClean="0"/>
               <a:t>n is the size of the problem</a:t>
             </a:r>
+            <a:endParaRPr lang="en-US" sz="2800" dirty="0" smtClean="0"/>
           </a:p>
           <a:p>
             <a:pPr fontAlgn="base"/>
@@ -4951,6 +4901,7 @@
               <a:rPr lang="en-US" sz="2800" dirty="0" smtClean="0"/>
               <a:t> (b &gt; 1)</a:t>
             </a:r>
+            <a:endParaRPr lang="en-US" sz="2800" dirty="0" smtClean="0"/>
           </a:p>
           <a:p>
             <a:pPr fontAlgn="base"/>
@@ -4998,7 +4949,7 @@
           </p:nvPr>
         </p:nvPicPr>
         <p:blipFill>
-          <a:blip r:embed="rId2" cstate="print"/>
+          <a:blip r:embed="rId1" cstate="print"/>
           <a:srcRect/>
           <a:stretch>
             <a:fillRect/>
@@ -5057,7 +5008,7 @@
           </p:nvPr>
         </p:nvPicPr>
         <p:blipFill>
-          <a:blip r:embed="rId2" cstate="print"/>
+          <a:blip r:embed="rId1" cstate="print"/>
           <a:srcRect/>
           <a:stretch>
             <a:fillRect/>
@@ -5134,6 +5085,7 @@
               <a:rPr lang="en-US" dirty="0" smtClean="0"/>
               <a:t>Hence, the running time can be expressed as:</a:t>
             </a:r>
+            <a:endParaRPr lang="en-US" dirty="0" smtClean="0"/>
           </a:p>
           <a:p>
             <a:pPr fontAlgn="base">
@@ -5149,12 +5101,9 @@
             </a:r>
             <a:r>
               <a:rPr lang="en-US" dirty="0" smtClean="0"/>
-              <a:t>(n/b) + f(n</a:t>
-            </a:r>
-            <a:r>
-              <a:rPr lang="en-US" dirty="0" smtClean="0"/>
-              <a:t>)</a:t>
-            </a:r>
+              <a:t>(n/b) + f(n)</a:t>
+            </a:r>
+            <a:endParaRPr lang="en-US" dirty="0" smtClean="0"/>
           </a:p>
           <a:p>
             <a:pPr fontAlgn="base">
@@ -5170,6 +5119,7 @@
               <a:rPr lang="en-US" b="1" dirty="0" smtClean="0"/>
               <a:t>When Master Theorem Cannot Be Applied</a:t>
             </a:r>
+            <a:endParaRPr lang="en-US" b="1" dirty="0" smtClean="0"/>
           </a:p>
           <a:p>
             <a:pPr fontAlgn="base">
@@ -5179,6 +5129,7 @@
               <a:rPr lang="en-US" dirty="0" smtClean="0"/>
               <a:t>The Master Theorem does not apply in the following cases:</a:t>
             </a:r>
+            <a:endParaRPr lang="en-US" dirty="0" smtClean="0"/>
           </a:p>
           <a:p>
             <a:pPr fontAlgn="base">
@@ -5195,6 +5146,7 @@
               <a:rPr lang="en-US" dirty="0" smtClean="0"/>
               <a:t>Example: T(n) = sin⁡(n)</a:t>
             </a:r>
+            <a:endParaRPr lang="en-US" dirty="0" smtClean="0"/>
           </a:p>
           <a:p>
             <a:pPr fontAlgn="base">
@@ -5209,15 +5161,7 @@
             </a:br>
             <a:r>
               <a:rPr lang="en-US" dirty="0" smtClean="0"/>
-              <a:t>Example</a:t>
-            </a:r>
-            <a:r>
-              <a:rPr lang="en-US" dirty="0" smtClean="0"/>
-              <a:t>: T(n</a:t>
-            </a:r>
-            <a:r>
-              <a:rPr lang="en-US" dirty="0" smtClean="0"/>
-              <a:t>) = 2T(n/2) + 2</a:t>
+              <a:t>Example: T(n) = 2T(n/2) + 2</a:t>
             </a:r>
             <a:r>
               <a:rPr lang="en-US" baseline="30000" dirty="0" smtClean="0"/>
@@ -5280,6 +5224,7 @@
               <a:rPr lang="en-US" b="1" dirty="0" smtClean="0"/>
               <a:t>How does the theorem work?</a:t>
             </a:r>
+            <a:endParaRPr lang="en-US" b="1" dirty="0" smtClean="0"/>
           </a:p>
           <a:p>
             <a:pPr fontAlgn="base"/>
@@ -5289,7 +5234,7 @@
             </a:r>
             <a:r>
               <a:rPr lang="en-US" u="sng" dirty="0" smtClean="0">
-                <a:hlinkClick r:id="rId2"/>
+                <a:hlinkClick r:id="rId1"/>
               </a:rPr>
               <a:t>recurrence tree method</a:t>
             </a:r>
@@ -5349,6 +5294,7 @@
               <a:rPr lang="en-US" dirty="0" smtClean="0"/>
               <a:t> </a:t>
             </a:r>
+            <a:endParaRPr lang="en-US" dirty="0" smtClean="0"/>
           </a:p>
           <a:p>
             <a:endParaRPr lang="en-US" dirty="0"/>
@@ -5364,7 +5310,7 @@
           <p:nvPr/>
         </p:nvPicPr>
         <p:blipFill>
-          <a:blip r:embed="rId3" cstate="print"/>
+          <a:blip r:embed="rId2" cstate="print"/>
           <a:srcRect/>
           <a:stretch>
             <a:fillRect/>
@@ -5461,18 +5407,21 @@
               <a:rPr lang="en-US" dirty="0" smtClean="0"/>
               <a:t>Recursive algorithm is which calls itself directly or indirectly</a:t>
             </a:r>
+            <a:endParaRPr lang="en-US" dirty="0" smtClean="0"/>
           </a:p>
           <a:p>
             <a:r>
               <a:rPr lang="en-US" dirty="0" smtClean="0"/>
               <a:t>Recurrence Relation: “A relation which can be represented by using its previous results”</a:t>
             </a:r>
+            <a:endParaRPr lang="en-US" dirty="0" smtClean="0"/>
           </a:p>
           <a:p>
             <a:r>
               <a:rPr lang="en-US" dirty="0" smtClean="0"/>
               <a:t>We use recurrence relations to find the time complexity of Recursive algorithms.</a:t>
             </a:r>
+            <a:endParaRPr lang="en-US" dirty="0" smtClean="0"/>
           </a:p>
           <a:p>
             <a:r>
@@ -5551,6 +5500,7 @@
               <a:rPr lang="en-US" dirty="0" smtClean="0"/>
               <a:t> more, then leaves are the dominant part, and our result becomes the work done at leaves (Case 1). If work done at leaves and root is asymptotically the same, then our result becomes height multiplied by work done at any level (Case 2). If work done at the root is asymptotically more, then our result becomes work done at the root (Case 3). </a:t>
             </a:r>
+            <a:endParaRPr lang="en-US" dirty="0" smtClean="0"/>
           </a:p>
           <a:p>
             <a:pPr fontAlgn="base"/>
@@ -5558,6 +5508,7 @@
               <a:rPr lang="en-US" b="1" dirty="0" smtClean="0"/>
               <a:t>Key Points</a:t>
             </a:r>
+            <a:endParaRPr lang="en-US" b="1" dirty="0" smtClean="0"/>
           </a:p>
           <a:p>
             <a:pPr fontAlgn="base"/>
@@ -5565,6 +5516,7 @@
               <a:rPr lang="en-US" dirty="0" smtClean="0"/>
               <a:t>The Master Theorem is specifically designed for divide-and-conquer recurrences</a:t>
             </a:r>
+            <a:endParaRPr lang="en-US" dirty="0" smtClean="0"/>
           </a:p>
           <a:p>
             <a:pPr fontAlgn="base"/>
@@ -5580,15 +5532,7 @@
             </a:pPr>
             <a:r>
               <a:rPr lang="en-US" dirty="0" smtClean="0"/>
-              <a:t>	</a:t>
-            </a:r>
-            <a:r>
-              <a:rPr lang="en-US" dirty="0" smtClean="0"/>
-              <a:t>	T(n</a:t>
-            </a:r>
-            <a:r>
-              <a:rPr lang="en-US" dirty="0" smtClean="0"/>
-              <a:t>) = </a:t>
+              <a:t>		T(n) = </a:t>
             </a:r>
             <a:r>
               <a:rPr lang="en-US" dirty="0" err="1" smtClean="0"/>
@@ -5598,6 +5542,7 @@
               <a:rPr lang="en-US" dirty="0" smtClean="0"/>
               <a:t>(n/b) + f(n)</a:t>
             </a:r>
+            <a:endParaRPr lang="en-US" dirty="0" smtClean="0"/>
           </a:p>
           <a:p>
             <a:pPr fontAlgn="base"/>
@@ -5605,6 +5550,7 @@
               <a:rPr lang="en-US" dirty="0" smtClean="0"/>
               <a:t>It provides a quick and reliable way to compute asymptotic time complexity</a:t>
             </a:r>
+            <a:endParaRPr lang="en-US" dirty="0" smtClean="0"/>
           </a:p>
           <a:p>
             <a:pPr fontAlgn="base"/>
@@ -5612,6 +5558,7 @@
               <a:rPr lang="en-US" dirty="0" smtClean="0"/>
               <a:t>Not all recurrences can be solved using this method</a:t>
             </a:r>
+            <a:endParaRPr lang="en-US" dirty="0" smtClean="0"/>
           </a:p>
           <a:p>
             <a:pPr fontAlgn="base"/>
@@ -5619,6 +5566,7 @@
               <a:rPr lang="en-US" dirty="0" smtClean="0"/>
               <a:t>For unsupported cases, we either use Substitution Method or Recurrence Tree Method</a:t>
             </a:r>
+            <a:endParaRPr lang="en-US" dirty="0" smtClean="0"/>
           </a:p>
           <a:p>
             <a:endParaRPr lang="en-US" dirty="0"/>
@@ -5698,6 +5646,7 @@
               <a:rPr lang="en-US" dirty="0" smtClean="0"/>
               <a:t>Amortized analysis studies the average cost of operations over a sequence, rather than focusing on the worst-case of a single operation.</a:t>
             </a:r>
+            <a:endParaRPr lang="en-US" dirty="0" smtClean="0"/>
           </a:p>
           <a:p>
             <a:pPr fontAlgn="base"/>
@@ -5705,6 +5654,7 @@
               <a:rPr lang="en-US" dirty="0" smtClean="0"/>
               <a:t>It is especially useful for dynamic data structures like arrays, hash tables, and trees, where occasional expensive operations occur.</a:t>
             </a:r>
+            <a:endParaRPr lang="en-US" dirty="0" smtClean="0"/>
           </a:p>
           <a:p>
             <a:pPr fontAlgn="base"/>
@@ -5712,6 +5662,7 @@
               <a:rPr lang="en-US" dirty="0" smtClean="0"/>
               <a:t>By spreading the cost of rare costly operations across many cheap ones, it gives a realistic measure of algorithm efficiency.</a:t>
             </a:r>
+            <a:endParaRPr lang="en-US" dirty="0" smtClean="0"/>
           </a:p>
           <a:p>
             <a:endParaRPr lang="en-US" dirty="0"/>
@@ -5771,12 +5722,9 @@
             </a:r>
             <a:r>
               <a:rPr lang="en-US" dirty="0" smtClean="0"/>
-              <a:t>: In a dynamic array, inserting elements is usually cheap (O(1)), but occasionally the array needs resizing, which is costly. By spreading the cost of resizing over all insertions, the amortized cost per insertion remains O(1</a:t>
-            </a:r>
-            <a:r>
-              <a:rPr lang="en-US" dirty="0" smtClean="0"/>
-              <a:t>).</a:t>
-            </a:r>
+              <a:t>: In a dynamic array, inserting elements is usually cheap (O(1)), but occasionally the array needs resizing, which is costly. By spreading the cost of resizing over all insertions, the amortized cost per insertion remains O(1).</a:t>
+            </a:r>
+            <a:endParaRPr lang="en-US" dirty="0" smtClean="0"/>
           </a:p>
           <a:p>
             <a:endParaRPr lang="en-US" dirty="0" smtClean="0"/>
@@ -5787,6 +5735,7 @@
               <a:rPr lang="en-US" b="1" dirty="0" smtClean="0"/>
               <a:t>Techniques of Amortized Analysis</a:t>
             </a:r>
+            <a:endParaRPr lang="en-US" b="1" dirty="0" smtClean="0"/>
           </a:p>
           <a:p>
             <a:pPr fontAlgn="base">
@@ -5794,12 +5743,9 @@
             </a:pPr>
             <a:r>
               <a:rPr lang="en-US" dirty="0" smtClean="0"/>
-              <a:t>   There </a:t>
-            </a:r>
-            <a:r>
-              <a:rPr lang="en-US" dirty="0" smtClean="0"/>
-              <a:t>are three standard methods to perform amortized analysis:</a:t>
-            </a:r>
+              <a:t>   There are three standard methods to perform amortized analysis:</a:t>
+            </a:r>
+            <a:endParaRPr lang="en-US" dirty="0" smtClean="0"/>
           </a:p>
           <a:p>
             <a:pPr fontAlgn="base">
@@ -5817,11 +5763,7 @@
             </a:pPr>
             <a:r>
               <a:rPr lang="en-US" dirty="0" smtClean="0"/>
-              <a:t>Compute the total cost of </a:t>
-            </a:r>
-            <a:r>
-              <a:rPr lang="en-US" dirty="0" smtClean="0"/>
-              <a:t>𝑛</a:t>
+              <a:t>Compute the total cost of 𝑛</a:t>
             </a:r>
             <a:r>
               <a:rPr lang="en-US" dirty="0" err="1" smtClean="0"/>
@@ -5829,12 +5771,9 @@
             </a:r>
             <a:r>
               <a:rPr lang="en-US" dirty="0" smtClean="0"/>
-              <a:t> </a:t>
-            </a:r>
-            <a:r>
-              <a:rPr lang="en-US" dirty="0" smtClean="0"/>
-              <a:t>operations and divide it by number of operations to obtain the average cost..</a:t>
-            </a:r>
+              <a:t> operations and divide it by number of operations to obtain the average cost..</a:t>
+            </a:r>
+            <a:endParaRPr lang="en-US" dirty="0" smtClean="0"/>
           </a:p>
           <a:p>
             <a:pPr fontAlgn="base">
@@ -5844,6 +5783,7 @@
               <a:rPr lang="en-US" dirty="0" smtClean="0"/>
               <a:t>Example: Dynamic array insertions involve occasional costly resizes, but the average cost per insertion is low.</a:t>
             </a:r>
+            <a:endParaRPr lang="en-US" dirty="0" smtClean="0"/>
           </a:p>
           <a:p>
             <a:endParaRPr lang="en-US" dirty="0"/>
@@ -5914,6 +5854,7 @@
               <a:rPr lang="en-US" dirty="0" smtClean="0"/>
               <a:t>Assign credits to operations.</a:t>
             </a:r>
+            <a:endParaRPr lang="en-US" dirty="0" smtClean="0"/>
           </a:p>
           <a:p>
             <a:pPr fontAlgn="base">
@@ -5921,12 +5862,9 @@
             </a:pPr>
             <a:r>
               <a:rPr lang="en-US" dirty="0" smtClean="0"/>
-              <a:t>Cheap operations save credits to pay for future expensive operations</a:t>
-            </a:r>
-            <a:r>
-              <a:rPr lang="en-US" dirty="0" smtClean="0"/>
-              <a:t>.</a:t>
-            </a:r>
+              <a:t>Cheap operations save credits to pay for future expensive operations.</a:t>
+            </a:r>
+            <a:endParaRPr lang="en-US" dirty="0" smtClean="0"/>
           </a:p>
           <a:p>
             <a:pPr fontAlgn="base">
@@ -5952,6 +5890,7 @@
               <a:rPr lang="en-US" dirty="0" smtClean="0"/>
               <a:t>Define a potential function φ representing the “stored work” in a data structure.</a:t>
             </a:r>
+            <a:endParaRPr lang="en-US" dirty="0" smtClean="0"/>
           </a:p>
           <a:p>
             <a:pPr fontAlgn="base">
@@ -5961,6 +5900,7 @@
               <a:rPr lang="en-US" dirty="0" smtClean="0"/>
               <a:t>Amortized cost = actual cost + change in potential.</a:t>
             </a:r>
+            <a:endParaRPr lang="en-US" dirty="0" smtClean="0"/>
           </a:p>
           <a:p>
             <a:pPr fontAlgn="base">
@@ -5970,6 +5910,7 @@
               <a:rPr lang="en-US" dirty="0" smtClean="0"/>
               <a:t>Commonly used in balanced trees like Red-Black Trees.</a:t>
             </a:r>
+            <a:endParaRPr lang="en-US" dirty="0" smtClean="0"/>
           </a:p>
           <a:p>
             <a:pPr>
@@ -6024,6 +5965,7 @@
               <a:rPr lang="en-US" dirty="0" smtClean="0"/>
               <a:t>The solution is to increase the table size whenever it's full. Here are the steps:</a:t>
             </a:r>
+            <a:endParaRPr lang="en-US" dirty="0" smtClean="0"/>
           </a:p>
           <a:p>
             <a:pPr fontAlgn="base"/>
@@ -6031,6 +5973,7 @@
               <a:rPr lang="en-US" dirty="0" smtClean="0"/>
               <a:t>Allocate memory for a larger table, typically twice the size of the old table.</a:t>
             </a:r>
+            <a:endParaRPr lang="en-US" dirty="0" smtClean="0"/>
           </a:p>
           <a:p>
             <a:pPr fontAlgn="base"/>
@@ -6038,6 +5981,7 @@
               <a:rPr lang="en-US" dirty="0" smtClean="0"/>
               <a:t>Copy the contents of the old table to the new table.</a:t>
             </a:r>
+            <a:endParaRPr lang="en-US" dirty="0" smtClean="0"/>
           </a:p>
           <a:p>
             <a:pPr fontAlgn="base"/>
@@ -6045,6 +5989,7 @@
               <a:rPr lang="en-US" dirty="0" smtClean="0"/>
               <a:t>Free the old table.</a:t>
             </a:r>
+            <a:endParaRPr lang="en-US" dirty="0" smtClean="0"/>
           </a:p>
           <a:p>
             <a:pPr fontAlgn="base"/>
@@ -6052,6 +5997,7 @@
               <a:rPr lang="en-US" dirty="0" smtClean="0"/>
               <a:t>If space is available, insert a new item.</a:t>
             </a:r>
+            <a:endParaRPr lang="en-US" dirty="0" smtClean="0"/>
           </a:p>
           <a:p>
             <a:endParaRPr lang="en-US" dirty="0"/>
@@ -6094,7 +6040,7 @@
           </p:nvPr>
         </p:nvPicPr>
         <p:blipFill>
-          <a:blip r:embed="rId2" cstate="print"/>
+          <a:blip r:embed="rId1" cstate="print"/>
           <a:srcRect/>
           <a:stretch>
             <a:fillRect/>
@@ -6186,7 +6132,7 @@
           </p:nvPr>
         </p:nvPicPr>
         <p:blipFill>
-          <a:blip r:embed="rId2" cstate="print"/>
+          <a:blip r:embed="rId1" cstate="print"/>
           <a:srcRect/>
           <a:stretch>
             <a:fillRect/>
@@ -6232,11 +6178,7 @@
           <a:p>
             <a:r>
               <a:rPr lang="en-US" sz="2800" dirty="0" smtClean="0"/>
-              <a:t>Amortized Analysis proves the Dynamic Table scheme has O(1) insertion </a:t>
-            </a:r>
-            <a:r>
-              <a:rPr lang="en-US" sz="2800" dirty="0" smtClean="0"/>
-              <a:t>time</a:t>
+              <a:t>Amortized Analysis proves the Dynamic Table scheme has O(1) insertion time</a:t>
             </a:r>
             <a:endParaRPr lang="en-US" sz="2800" dirty="0"/>
           </a:p>
@@ -6278,7 +6220,7 @@
           </p:nvPr>
         </p:nvPicPr>
         <p:blipFill>
-          <a:blip r:embed="rId2" cstate="print"/>
+          <a:blip r:embed="rId1" cstate="print"/>
           <a:srcRect/>
           <a:stretch>
             <a:fillRect/>
@@ -6367,7 +6309,7 @@
           </p:nvPr>
         </p:nvPicPr>
         <p:blipFill>
-          <a:blip r:embed="rId2" cstate="print"/>
+          <a:blip r:embed="rId1" cstate="print"/>
           <a:srcRect/>
           <a:stretch>
             <a:fillRect/>
@@ -6399,7 +6341,7 @@
           <p:nvPr/>
         </p:nvPicPr>
         <p:blipFill>
-          <a:blip r:embed="rId3" cstate="print"/>
+          <a:blip r:embed="rId2" cstate="print"/>
           <a:srcRect/>
           <a:stretch>
             <a:fillRect/>
@@ -6458,7 +6400,7 @@
           </p:nvPr>
         </p:nvPicPr>
         <p:blipFill>
-          <a:blip r:embed="rId2" cstate="print"/>
+          <a:blip r:embed="rId1" cstate="print"/>
           <a:srcRect/>
           <a:stretch>
             <a:fillRect/>
@@ -6517,7 +6459,7 @@
           </p:nvPr>
         </p:nvPicPr>
         <p:blipFill>
-          <a:blip r:embed="rId2" cstate="print"/>
+          <a:blip r:embed="rId1" cstate="print"/>
           <a:srcRect/>
           <a:stretch>
             <a:fillRect/>
@@ -6621,6 +6563,7 @@
               <a:rPr lang="en-US" dirty="0" smtClean="0"/>
               <a:t>Recurrence relations can be solved by 3 methods </a:t>
             </a:r>
+            <a:endParaRPr lang="en-US" dirty="0" smtClean="0"/>
           </a:p>
           <a:p>
             <a:endParaRPr lang="en-US" dirty="0" smtClean="0"/>
@@ -6641,6 +6584,7 @@
               <a:rPr lang="en-US" dirty="0" smtClean="0"/>
               <a:t>: We guess the form of the solution and prove it using mathematical induction.</a:t>
             </a:r>
+            <a:endParaRPr lang="en-US" dirty="0" smtClean="0"/>
           </a:p>
           <a:p>
             <a:pPr>
@@ -6658,6 +6602,7 @@
               <a:rPr lang="en-US" dirty="0" smtClean="0"/>
               <a:t>: This method represents the recurrence as a tree and computes the total cost by summing the cost at each level. </a:t>
             </a:r>
+            <a:endParaRPr lang="en-US" dirty="0" smtClean="0"/>
           </a:p>
           <a:p>
             <a:pPr>
@@ -6748,6 +6693,7 @@
               <a:rPr lang="en-US" dirty="0" smtClean="0"/>
               <a:t>The Substitution Method is a technique used to find the time complexity of recursive algorithms by expanding the recurrence relation, identifying a pattern, and then proving the result using mathematical induction.</a:t>
             </a:r>
+            <a:endParaRPr lang="en-US" dirty="0" smtClean="0"/>
           </a:p>
           <a:p>
             <a:pPr fontAlgn="base"/>
@@ -6755,6 +6701,7 @@
               <a:rPr lang="en-US" dirty="0" smtClean="0"/>
               <a:t>Understand how the recursion works.</a:t>
             </a:r>
+            <a:endParaRPr lang="en-US" dirty="0" smtClean="0"/>
           </a:p>
           <a:p>
             <a:pPr fontAlgn="base"/>
@@ -6762,6 +6709,7 @@
               <a:rPr lang="en-US" dirty="0" smtClean="0"/>
               <a:t>Write the recurrence relation.</a:t>
             </a:r>
+            <a:endParaRPr lang="en-US" dirty="0" smtClean="0"/>
           </a:p>
           <a:p>
             <a:pPr fontAlgn="base"/>
@@ -6769,6 +6717,7 @@
               <a:rPr lang="en-US" dirty="0" smtClean="0"/>
               <a:t>Guess the solution based on the recursion pattern.</a:t>
             </a:r>
+            <a:endParaRPr lang="en-US" dirty="0" smtClean="0"/>
           </a:p>
           <a:p>
             <a:pPr fontAlgn="base"/>
@@ -6776,6 +6725,7 @@
               <a:rPr lang="en-US" dirty="0" smtClean="0"/>
               <a:t>Verify the guessed solution using Mathematical induction</a:t>
             </a:r>
+            <a:endParaRPr lang="en-US" dirty="0" smtClean="0"/>
           </a:p>
           <a:p>
             <a:endParaRPr lang="en-US" dirty="0"/>
@@ -6902,6 +6852,7 @@
               <a:rPr lang="en-US" dirty="0" smtClean="0"/>
               <a:t> n) {</a:t>
             </a:r>
+            <a:endParaRPr lang="en-US" dirty="0" smtClean="0"/>
           </a:p>
           <a:p>
             <a:pPr>
@@ -6911,6 +6862,7 @@
               <a:rPr lang="en-US" dirty="0" smtClean="0"/>
               <a:t>    if (n &lt;= 0)</a:t>
             </a:r>
+            <a:endParaRPr lang="en-US" dirty="0" smtClean="0"/>
           </a:p>
           <a:p>
             <a:pPr>
@@ -6920,6 +6872,7 @@
               <a:rPr lang="en-US" dirty="0" smtClean="0"/>
               <a:t>        return;</a:t>
             </a:r>
+            <a:endParaRPr lang="en-US" dirty="0" smtClean="0"/>
           </a:p>
           <a:p>
             <a:pPr>
@@ -6937,6 +6890,7 @@
               <a:rPr lang="en-US" dirty="0" smtClean="0"/>
               <a:t> &lt;&lt; "GFG";</a:t>
             </a:r>
+            <a:endParaRPr lang="en-US" dirty="0" smtClean="0"/>
           </a:p>
           <a:p>
             <a:pPr>
@@ -6946,6 +6900,7 @@
               <a:rPr lang="en-US" dirty="0" smtClean="0"/>
               <a:t>    fun(n / 2);</a:t>
             </a:r>
+            <a:endParaRPr lang="en-US" dirty="0" smtClean="0"/>
           </a:p>
           <a:p>
             <a:pPr>
@@ -6955,6 +6910,7 @@
               <a:rPr lang="en-US" dirty="0" smtClean="0"/>
               <a:t>    fun(n / 2);</a:t>
             </a:r>
+            <a:endParaRPr lang="en-US" dirty="0" smtClean="0"/>
           </a:p>
           <a:p>
             <a:pPr>
@@ -6964,6 +6920,7 @@
               <a:rPr lang="en-US" dirty="0" smtClean="0"/>
               <a:t>}</a:t>
             </a:r>
+            <a:endParaRPr lang="en-US" dirty="0" smtClean="0"/>
           </a:p>
           <a:p>
             <a:pPr fontAlgn="base">
@@ -6973,6 +6930,7 @@
               <a:rPr lang="en-US" b="1" dirty="0" smtClean="0"/>
               <a:t>Understanding the Recursion for This Code</a:t>
             </a:r>
+            <a:endParaRPr lang="en-US" b="1" dirty="0" smtClean="0"/>
           </a:p>
           <a:p>
             <a:pPr fontAlgn="base"/>
@@ -6980,6 +6938,7 @@
               <a:rPr lang="en-US" dirty="0" smtClean="0"/>
               <a:t>The function prints "GFG" once for each call.</a:t>
             </a:r>
+            <a:endParaRPr lang="en-US" dirty="0" smtClean="0"/>
           </a:p>
           <a:p>
             <a:pPr fontAlgn="base"/>
@@ -6987,6 +6946,7 @@
               <a:rPr lang="en-US" dirty="0" smtClean="0"/>
               <a:t>It makes two recursive calls, each with input size n/2.</a:t>
             </a:r>
+            <a:endParaRPr lang="en-US" dirty="0" smtClean="0"/>
           </a:p>
           <a:p>
             <a:pPr fontAlgn="base"/>
@@ -6994,6 +6954,7 @@
               <a:rPr lang="en-US" dirty="0" smtClean="0"/>
               <a:t>The recursion stops when n &lt;= 0.</a:t>
             </a:r>
+            <a:endParaRPr lang="en-US" dirty="0" smtClean="0"/>
           </a:p>
           <a:p>
             <a:pPr fontAlgn="base">
@@ -7003,6 +6964,7 @@
               <a:rPr lang="en-US" b="1" dirty="0" smtClean="0"/>
               <a:t>Writing the Recurrence Relation</a:t>
             </a:r>
+            <a:endParaRPr lang="en-US" b="1" dirty="0" smtClean="0"/>
           </a:p>
           <a:p>
             <a:pPr fontAlgn="base"/>
@@ -7010,6 +6972,7 @@
               <a:rPr lang="en-US" dirty="0" smtClean="0"/>
               <a:t>The work done in each function call is constant (printing "GFG"), and the function makes two recursive calls of size n/2. Therefore, the recurrence relation is: T(n) = 2T(n/2) + O(1)</a:t>
             </a:r>
+            <a:endParaRPr lang="en-US" dirty="0" smtClean="0"/>
           </a:p>
           <a:p>
             <a:pPr>
@@ -7073,6 +7036,7 @@
               <a:rPr lang="en-US" b="1" dirty="0" smtClean="0"/>
               <a:t>Applying the Substitution Method</a:t>
             </a:r>
+            <a:endParaRPr lang="en-US" b="1" dirty="0" smtClean="0"/>
           </a:p>
           <a:p>
             <a:pPr fontAlgn="base"/>
@@ -7102,6 +7066,7 @@
               <a:rPr lang="en-US" dirty="0" smtClean="0"/>
               <a:t>As the recursion continues, the number of function calls doubles at each level, and the recursion stops when the input size becomes constant, which happens after about log n levels.</a:t>
             </a:r>
+            <a:endParaRPr lang="en-US" dirty="0" smtClean="0"/>
           </a:p>
           <a:p>
             <a:pPr fontAlgn="base"/>
@@ -7109,6 +7074,7 @@
               <a:rPr lang="en-US" dirty="0" smtClean="0"/>
               <a:t>Hence, we guess that the time complexity is T(n) = O(n).</a:t>
             </a:r>
+            <a:endParaRPr lang="en-US" dirty="0" smtClean="0"/>
           </a:p>
           <a:p>
             <a:pPr fontAlgn="base"/>
@@ -7135,6 +7101,7 @@
               <a:rPr lang="en-US" dirty="0" smtClean="0"/>
               <a:t>Assume that this holds for smaller values of n, particularly for n/2: T(n/2) ≤ c(n/2)</a:t>
             </a:r>
+            <a:endParaRPr lang="en-US" dirty="0" smtClean="0"/>
           </a:p>
           <a:p>
             <a:pPr fontAlgn="base"/>
@@ -7217,6 +7184,7 @@
               <a:rPr lang="en-US" dirty="0" smtClean="0"/>
               <a:t>The assumption holds true, which confirms that the time complexity of the recurrence is: T(n) = O(n)</a:t>
             </a:r>
+            <a:endParaRPr lang="en-US" dirty="0" smtClean="0"/>
           </a:p>
           <a:p>
             <a:endParaRPr lang="en-US" dirty="0"/>
@@ -7521,7 +7489,10 @@
       </a:bgFillStyleLst>
     </a:fmtScheme>
   </a:themeElements>
-  <a:objectDefaults/>
-  <a:extraClrSchemeLst/>
+  <a:extLst>
+    <a:ext uri="{05A4C25C-085E-4340-85A3-A5531E510DB2}">
+      <thm15:themeFamily xmlns:thm15="http://schemas.microsoft.com/office/thememl/2012/main" name="Office Theme" id="{62F939B6-93AF-4DB8-9C6B-D6C7DFDC589F}" vid="{4A3C46E8-61CC-4603-A589-7422A47A8E4A}"/>
+    </a:ext>
+  </a:extLst>
 </a:theme>
 </file>
</xml_diff>